<commit_message>
Standardize daily success rate wording
Co-authored-by: ChantelleJ-pm <ChantelleJ-pm@users.noreply.github.com>
</commit_message>
<xml_diff>
--- a/Recipe_Clipper_Stakeholder_Update.pptx
+++ b/Recipe_Clipper_Stakeholder_Update.pptx
@@ -3320,13 +3320,7 @@
           <a:lstStyle/>
           <a:p>
             <a:r>
-              <a:rPr sz="1400" b="1">
-                <a:solidFill>
-                  <a:srgbClr val="344054"/>
-                </a:solidFill>
-                <a:latin typeface="Aptos"/>
-              </a:rPr>
-              <a:t>Save success rate</a:t>
+              <a:t>Average daily save attempt success rate</a:t>
             </a:r>
           </a:p>
         </p:txBody>
@@ -3896,35 +3890,13 @@
             </a:r>
           </a:p>
           <a:p>
-            <a:pPr>
-              <a:spcAft>
-                <a:spcPts val="800"/>
-              </a:spcAft>
-              <a:defRPr sz="1400">
-                <a:solidFill>
-                  <a:srgbClr val="344054"/>
-                </a:solidFill>
-                <a:latin typeface="Aptos"/>
-              </a:defRPr>
-            </a:pPr>
             <a:r>
               <a:t>User error rate improved from 35% to 25% of submissions in the immediate pre/post Feb 9 window</a:t>
             </a:r>
           </a:p>
           <a:p>
-            <a:pPr>
-              <a:spcAft>
-                <a:spcPts val="800"/>
-              </a:spcAft>
-              <a:defRPr sz="1400">
-                <a:solidFill>
-                  <a:srgbClr val="344054"/>
-                </a:solidFill>
-                <a:latin typeface="Aptos"/>
-              </a:defRPr>
-            </a:pPr>
-            <a:r>
-              <a:t>Save-click-to-success conversion improved from 47% to 54% after the site expansion</a:t>
+            <a:r>
+              <a:t>Average daily save attempt success rate improved from 44% to 50% after the site expansion and reached 52% in the trusted post-mid-Feb period</a:t>
             </a:r>
           </a:p>
         </p:txBody>

</xml_diff>

<commit_message>
Refine stakeholder slides with pre-Feb baseline
Co-authored-by: ChantelleJ-pm <ChantelleJ-pm@users.noreply.github.com>
</commit_message>
<xml_diff>
--- a/Recipe_Clipper_Stakeholder_Update.pptx
+++ b/Recipe_Clipper_Stakeholder_Update.pptx
@@ -3098,7 +3098,7 @@
         <p:spPr>
           <a:xfrm>
             <a:off x="502920" y="320040"/>
-            <a:ext cx="1828800" cy="347472"/>
+            <a:ext cx="1874519" cy="347472"/>
           </a:xfrm>
           <a:prstGeom prst="roundRect">
             <a:avLst/>
@@ -3150,7 +3150,7 @@
         <p:spPr>
           <a:xfrm>
             <a:off x="502920" y="786384"/>
-            <a:ext cx="11064240" cy="594360"/>
+            <a:ext cx="10972800" cy="640080"/>
           </a:xfrm>
           <a:prstGeom prst="rect">
             <a:avLst/>
@@ -3158,7 +3158,7 @@
           <a:noFill/>
         </p:spPr>
         <p:txBody>
-          <a:bodyPr wrap="square">
+          <a:bodyPr wrap="none">
             <a:spAutoFit/>
           </a:bodyPr>
           <a:lstStyle/>
@@ -3170,7 +3170,7 @@
                 </a:solidFill>
                 <a:latin typeface="Aptos Display"/>
               </a:rPr>
-              <a:t>Recipe Clipper is improving on key leading KPIs</a:t>
+              <a:t>Recipe Clipper is performing better now than it was before February</a:t>
             </a:r>
           </a:p>
         </p:txBody>
@@ -3183,8 +3183,8 @@
         </p:nvSpPr>
         <p:spPr>
           <a:xfrm>
-            <a:off x="521207" y="1325880"/>
-            <a:ext cx="10972800" cy="457200"/>
+            <a:off x="521207" y="1353312"/>
+            <a:ext cx="11064240" cy="502920"/>
           </a:xfrm>
           <a:prstGeom prst="rect">
             <a:avLst/>
@@ -3204,7 +3204,7 @@
                 </a:solidFill>
                 <a:latin typeface="Aptos"/>
               </a:rPr>
-              <a:t>The Feb 9 support-list expansion and the cleaner mid-Feb reporting period both point to a healthier core save flow.</a:t>
+              <a:t>Pre-Feb vs post-mid-Feb shows stronger save performance, faster save-click time, and continued external adoption.</a:t>
             </a:r>
           </a:p>
         </p:txBody>
@@ -3320,6 +3320,12 @@
           <a:lstStyle/>
           <a:p>
             <a:r>
+              <a:rPr sz="1400" b="1">
+                <a:solidFill>
+                  <a:srgbClr val="344054"/>
+                </a:solidFill>
+                <a:latin typeface="Aptos"/>
+              </a:rPr>
               <a:t>Average daily save attempt success rate</a:t>
             </a:r>
           </a:p>
@@ -3334,7 +3340,7 @@
         <p:spPr>
           <a:xfrm>
             <a:off x="694944" y="2395728"/>
-            <a:ext cx="3328416" cy="640080"/>
+            <a:ext cx="3328416" cy="685800"/>
           </a:xfrm>
           <a:prstGeom prst="rect">
             <a:avLst/>
@@ -3354,7 +3360,7 @@
                 </a:solidFill>
                 <a:latin typeface="Aptos Display"/>
               </a:rPr>
-              <a:t>44% -&gt; 50% -&gt; 52%</a:t>
+              <a:t>40.5% -&gt; 52.1%</a:t>
             </a:r>
           </a:p>
         </p:txBody>
@@ -3368,7 +3374,7 @@
         <p:spPr>
           <a:xfrm>
             <a:off x="694944" y="3090672"/>
-            <a:ext cx="3328416" cy="457200"/>
+            <a:ext cx="3328416" cy="502920"/>
           </a:xfrm>
           <a:prstGeom prst="rect">
             <a:avLst/>
@@ -3388,7 +3394,7 @@
                 </a:solidFill>
                 <a:latin typeface="Aptos"/>
               </a:rPr>
-              <a:t>Feb 1-8 -&gt; Feb 9-18 -&gt; post-mid-Feb baseline</a:t>
+              <a:t>Pre-Feb (12/18-1/31) -&gt; post-mid-Feb (2/19-3/18)</a:t>
             </a:r>
           </a:p>
         </p:txBody>
@@ -3524,7 +3530,7 @@
         <p:spPr>
           <a:xfrm>
             <a:off x="4453128" y="2395728"/>
-            <a:ext cx="3328416" cy="640080"/>
+            <a:ext cx="3328416" cy="685800"/>
           </a:xfrm>
           <a:prstGeom prst="rect">
             <a:avLst/>
@@ -3544,7 +3550,7 @@
                 </a:solidFill>
                 <a:latin typeface="Aptos Display"/>
               </a:rPr>
-              <a:t>5.2s -&gt; 4.3s -&gt; 3.8s</a:t>
+              <a:t>5.1s -&gt; 3.8s</a:t>
             </a:r>
           </a:p>
         </p:txBody>
@@ -3558,7 +3564,7 @@
         <p:spPr>
           <a:xfrm>
             <a:off x="4453128" y="3090672"/>
-            <a:ext cx="3328416" cy="457200"/>
+            <a:ext cx="3328416" cy="502920"/>
           </a:xfrm>
           <a:prstGeom prst="rect">
             <a:avLst/>
@@ -3578,7 +3584,7 @@
                 </a:solidFill>
                 <a:latin typeface="Aptos"/>
               </a:rPr>
-              <a:t>Faster saves after 126 sites were added on Feb 9</a:t>
+              <a:t>Pre-Feb (12/18-1/31) -&gt; post-mid-Feb (2/19-3/18)</a:t>
             </a:r>
           </a:p>
         </p:txBody>
@@ -3714,7 +3720,7 @@
         <p:spPr>
           <a:xfrm>
             <a:off x="8211312" y="2395728"/>
-            <a:ext cx="3328416" cy="640080"/>
+            <a:ext cx="3328416" cy="685800"/>
           </a:xfrm>
           <a:prstGeom prst="rect">
             <a:avLst/>
@@ -3734,7 +3740,7 @@
                 </a:solidFill>
                 <a:latin typeface="Aptos Display"/>
               </a:rPr>
-              <a:t>85% of successful saves</a:t>
+              <a:t>78.8% -&gt; 85.3%</a:t>
             </a:r>
           </a:p>
         </p:txBody>
@@ -3748,7 +3754,7 @@
         <p:spPr>
           <a:xfrm>
             <a:off x="8211312" y="3090672"/>
-            <a:ext cx="3328416" cy="457200"/>
+            <a:ext cx="3328416" cy="502920"/>
           </a:xfrm>
           <a:prstGeom prst="rect">
             <a:avLst/>
@@ -3768,7 +3774,7 @@
                 </a:solidFill>
                 <a:latin typeface="Aptos"/>
               </a:rPr>
-              <a:t>Post-mid-Feb successful saves are overwhelmingly external-brand URLs</a:t>
+              <a:t>Share of successful saves that are external-brand URLs</a:t>
             </a:r>
           </a:p>
         </p:txBody>
@@ -3847,7 +3853,7 @@
                 </a:solidFill>
                 <a:latin typeface="Aptos"/>
               </a:rPr>
-              <a:t>What improved</a:t>
+              <a:t>What to say on the slide</a:t>
             </a:r>
           </a:p>
         </p:txBody>
@@ -3860,8 +3866,8 @@
         </p:nvSpPr>
         <p:spPr>
           <a:xfrm>
-            <a:off x="676656" y="4361688"/>
-            <a:ext cx="6245352" cy="1636776"/>
+            <a:off x="676656" y="4343400"/>
+            <a:ext cx="6245352" cy="1673352"/>
           </a:xfrm>
           <a:prstGeom prst="rect">
             <a:avLst/>
@@ -3890,13 +3896,35 @@
             </a:r>
           </a:p>
           <a:p>
-            <a:r>
-              <a:t>User error rate improved from 35% to 25% of submissions in the immediate pre/post Feb 9 window</a:t>
-            </a:r>
-          </a:p>
-          <a:p>
-            <a:r>
-              <a:t>Average daily save attempt success rate improved from 44% to 50% after the site expansion and reached 52% in the trusted post-mid-Feb period</a:t>
+            <a:pPr>
+              <a:spcAft>
+                <a:spcPts val="800"/>
+              </a:spcAft>
+              <a:defRPr sz="1400">
+                <a:solidFill>
+                  <a:srgbClr val="344054"/>
+                </a:solidFill>
+                <a:latin typeface="Aptos"/>
+              </a:defRPr>
+            </a:pPr>
+            <a:r>
+              <a:t>Average daily save attempt success rate improved from 44.1% in Feb 1-8 to 50.3% in Feb 9-18</a:t>
+            </a:r>
+          </a:p>
+          <a:p>
+            <a:pPr>
+              <a:spcAft>
+                <a:spcPts val="800"/>
+              </a:spcAft>
+              <a:defRPr sz="1400">
+                <a:solidFill>
+                  <a:srgbClr val="344054"/>
+                </a:solidFill>
+                <a:latin typeface="Aptos"/>
+              </a:defRPr>
+            </a:pPr>
+            <a:r>
+              <a:t>User error rate improved from 35.1% to 24.9% of submissions in the immediate pre/post Feb 9 window</a:t>
             </a:r>
           </a:p>
         </p:txBody>
@@ -3937,7 +3965,7 @@
           </a:fontRef>
         </p:style>
         <p:txBody>
-          <a:bodyPr rtlCol="0" anchor="ctr" wrap="square" lIns="164592" rIns="164592" tIns="146304"/>
+          <a:bodyPr rtlCol="0" anchor="ctr" wrap="square"/>
           <a:lstStyle/>
           <a:p>
             <a:pPr algn="ctr"/>
@@ -3964,7 +3992,7 @@
               </a:defRPr>
             </a:pPr>
             <a:r>
-              <a:t>We are making progress on the leading KPIs we can validate in this export: reliability, speed, and external recipe adoption.</a:t>
+              <a:t>We are performing better now than we were before February on the leading KPIs visible in this export.</a:t>
             </a:r>
           </a:p>
           <a:p>
@@ -3994,7 +4022,7 @@
         <p:spPr>
           <a:xfrm>
             <a:off x="530352" y="6419088"/>
-            <a:ext cx="10972800" cy="228600"/>
+            <a:ext cx="10972800" cy="201168"/>
           </a:xfrm>
           <a:prstGeom prst="rect">
             <a:avLst/>
@@ -4014,7 +4042,7 @@
                 </a:solidFill>
                 <a:latin typeface="Aptos"/>
               </a:rPr>
-              <a:t>Trusted error attribution starts 2/19 after the save URL error-category update. KPI progress before then is best used directionally.</a:t>
+              <a:t>Use pre-Feb vs post-mid-Feb for the topline before/after story. Use 2/19 onward as the trusted source for user vs product vs external error attribution.</a:t>
             </a:r>
           </a:p>
         </p:txBody>
@@ -4046,7 +4074,7 @@
         <p:spPr>
           <a:xfrm>
             <a:off x="502920" y="320040"/>
-            <a:ext cx="1828800" cy="347472"/>
+            <a:ext cx="1874519" cy="347472"/>
           </a:xfrm>
           <a:prstGeom prst="roundRect">
             <a:avLst/>
@@ -4098,7 +4126,7 @@
         <p:spPr>
           <a:xfrm>
             <a:off x="502920" y="786384"/>
-            <a:ext cx="11064240" cy="594360"/>
+            <a:ext cx="10972800" cy="640080"/>
           </a:xfrm>
           <a:prstGeom prst="rect">
             <a:avLst/>
@@ -4106,7 +4134,7 @@
           <a:noFill/>
         </p:spPr>
         <p:txBody>
-          <a:bodyPr wrap="square">
+          <a:bodyPr wrap="none">
             <a:spAutoFit/>
           </a:bodyPr>
           <a:lstStyle/>
@@ -4131,8 +4159,8 @@
         </p:nvSpPr>
         <p:spPr>
           <a:xfrm>
-            <a:off x="521207" y="1325880"/>
-            <a:ext cx="10972800" cy="457200"/>
+            <a:off x="521207" y="1353312"/>
+            <a:ext cx="11064240" cy="502920"/>
           </a:xfrm>
           <a:prstGeom prst="rect">
             <a:avLst/>
@@ -4243,7 +4271,7 @@
         <p:spPr>
           <a:xfrm>
             <a:off x="868680" y="2743200"/>
-            <a:ext cx="2948025" cy="731520"/>
+            <a:ext cx="2977515" cy="731520"/>
           </a:xfrm>
           <a:prstGeom prst="rect">
             <a:avLst/>
@@ -4286,7 +4314,7 @@
         <p:spPr>
           <a:xfrm>
             <a:off x="896112" y="2898648"/>
-            <a:ext cx="2893161" cy="320040"/>
+            <a:ext cx="2922651" cy="320040"/>
           </a:xfrm>
           <a:prstGeom prst="rect">
             <a:avLst/>
@@ -4294,7 +4322,7 @@
           <a:noFill/>
         </p:spPr>
         <p:txBody>
-          <a:bodyPr wrap="square">
+          <a:bodyPr wrap="none">
             <a:spAutoFit/>
           </a:bodyPr>
           <a:lstStyle/>
@@ -4307,7 +4335,7 @@
                 </a:solidFill>
                 <a:latin typeface="Aptos"/>
               </a:rPr>
-              <a:t>Success 52%</a:t>
+              <a:t>Success 52.1%</a:t>
             </a:r>
           </a:p>
         </p:txBody>
@@ -4320,8 +4348,8 @@
         </p:nvSpPr>
         <p:spPr>
           <a:xfrm>
-            <a:off x="3816705" y="2743200"/>
-            <a:ext cx="1417320" cy="731520"/>
+            <a:off x="3846195" y="2743200"/>
+            <a:ext cx="1400175" cy="731520"/>
           </a:xfrm>
           <a:prstGeom prst="rect">
             <a:avLst/>
@@ -4363,8 +4391,8 @@
         </p:nvSpPr>
         <p:spPr>
           <a:xfrm>
-            <a:off x="3844137" y="2898648"/>
-            <a:ext cx="1362456" cy="320040"/>
+            <a:off x="3873627" y="2898648"/>
+            <a:ext cx="1345311" cy="320040"/>
           </a:xfrm>
           <a:prstGeom prst="rect">
             <a:avLst/>
@@ -4372,7 +4400,7 @@
           <a:noFill/>
         </p:spPr>
         <p:txBody>
-          <a:bodyPr wrap="square">
+          <a:bodyPr wrap="none">
             <a:spAutoFit/>
           </a:bodyPr>
           <a:lstStyle/>
@@ -4385,7 +4413,7 @@
                 </a:solidFill>
                 <a:latin typeface="Aptos"/>
               </a:rPr>
-              <a:t>User 25%</a:t>
+              <a:t>User 24.5%</a:t>
             </a:r>
           </a:p>
         </p:txBody>
@@ -4398,8 +4426,8 @@
         </p:nvSpPr>
         <p:spPr>
           <a:xfrm>
-            <a:off x="5234025" y="2743200"/>
-            <a:ext cx="737006" cy="731520"/>
+            <a:off x="5246370" y="2743200"/>
+            <a:ext cx="720090" cy="731520"/>
           </a:xfrm>
           <a:prstGeom prst="rect">
             <a:avLst/>
@@ -4441,8 +4469,8 @@
         </p:nvSpPr>
         <p:spPr>
           <a:xfrm>
-            <a:off x="5261457" y="2898648"/>
-            <a:ext cx="682142" cy="320040"/>
+            <a:off x="5273802" y="2898648"/>
+            <a:ext cx="665226" cy="320040"/>
           </a:xfrm>
           <a:prstGeom prst="rect">
             <a:avLst/>
@@ -4450,7 +4478,7 @@
           <a:noFill/>
         </p:spPr>
         <p:txBody>
-          <a:bodyPr wrap="square">
+          <a:bodyPr wrap="none">
             <a:spAutoFit/>
           </a:bodyPr>
           <a:lstStyle/>
@@ -4463,7 +4491,7 @@
                 </a:solidFill>
                 <a:latin typeface="Aptos"/>
               </a:rPr>
-              <a:t>External 13%</a:t>
+              <a:t>External 12.6%</a:t>
             </a:r>
           </a:p>
         </p:txBody>
@@ -4476,8 +4504,8 @@
         </p:nvSpPr>
         <p:spPr>
           <a:xfrm>
-            <a:off x="5971032" y="2743200"/>
-            <a:ext cx="566928" cy="731520"/>
+            <a:off x="5966459" y="2743200"/>
+            <a:ext cx="571500" cy="731520"/>
           </a:xfrm>
           <a:prstGeom prst="rect">
             <a:avLst/>
@@ -4519,8 +4547,8 @@
         </p:nvSpPr>
         <p:spPr>
           <a:xfrm>
-            <a:off x="5998464" y="2898648"/>
-            <a:ext cx="512064" cy="320040"/>
+            <a:off x="5993892" y="2898648"/>
+            <a:ext cx="516635" cy="320040"/>
           </a:xfrm>
           <a:prstGeom prst="rect">
             <a:avLst/>
@@ -4528,7 +4556,7 @@
           <a:noFill/>
         </p:spPr>
         <p:txBody>
-          <a:bodyPr wrap="square">
+          <a:bodyPr wrap="none">
             <a:spAutoFit/>
           </a:bodyPr>
           <a:lstStyle/>
@@ -4541,7 +4569,7 @@
                 </a:solidFill>
                 <a:latin typeface="Aptos"/>
               </a:rPr>
-              <a:t>Product 10%</a:t>
+              <a:t>Product 10.0%</a:t>
             </a:r>
           </a:p>
         </p:txBody>
@@ -4580,7 +4608,7 @@
               </a:defRPr>
             </a:pPr>
             <a:r>
-              <a:t>Product-side issues are about 10% of save attempts in the trusted post-mid-Feb period.</a:t>
+              <a:t>Product-side issues are about 10.0% of save attempts in the trusted post-mid-Feb period.</a:t>
             </a:r>
           </a:p>
           <a:p>
@@ -4596,7 +4624,7 @@
               </a:defRPr>
             </a:pPr>
             <a:r>
-              <a:t>If someone asks about the 21% figure, clarify that it is the share of classified failures, not the share of all attempts.</a:t>
+              <a:t>If someone asks about the 21.1% figure, clarify that it is the share of classified failures, not the share of all attempts.</a:t>
             </a:r>
           </a:p>
         </p:txBody>
@@ -4618,7 +4646,7 @@
           <a:solidFill>
             <a:srgbClr val="FFFFFF"/>
           </a:solidFill>
-          <a:ln w="15240">
+          <a:ln w="16510">
             <a:solidFill>
               <a:srgbClr val="4F73FF"/>
             </a:solidFill>
@@ -4639,27 +4667,50 @@
           </a:fontRef>
         </p:style>
         <p:txBody>
-          <a:bodyPr rtlCol="0" anchor="ctr" wrap="square" lIns="109728" rIns="109728" tIns="109728" bIns="109728">
-            <a:normAutofit/>
+          <a:bodyPr rtlCol="0" anchor="ctr"/>
+          <a:lstStyle/>
+          <a:p>
+            <a:pPr algn="ctr"/>
+          </a:p>
+        </p:txBody>
+      </p:sp>
+      <p:sp>
+        <p:nvSpPr>
+          <p:cNvPr id="17" name="TextBox 16"/>
+          <p:cNvSpPr txBox="1"/>
+          <p:nvPr/>
+        </p:nvSpPr>
+        <p:spPr>
+          <a:xfrm>
+            <a:off x="7525512" y="2029967"/>
+            <a:ext cx="3977639" cy="685800"/>
+          </a:xfrm>
+          <a:prstGeom prst="rect">
+            <a:avLst/>
+          </a:prstGeom>
+          <a:noFill/>
+        </p:spPr>
+        <p:txBody>
+          <a:bodyPr wrap="none">
+            <a:spAutoFit/>
           </a:bodyPr>
           <a:lstStyle/>
           <a:p>
-            <a:pPr algn="l"/>
-            <a:r>
-              <a:rPr sz="2200" b="1">
+            <a:r>
+              <a:rPr sz="2000" b="1">
                 <a:solidFill>
                   <a:srgbClr val="0B1F3A"/>
                 </a:solidFill>
-                <a:latin typeface="Aptos"/>
+                <a:latin typeface="Aptos Display"/>
               </a:rPr>
-              <a:t>92% of external errors are unsupported-site related</a:t>
-            </a:r>
-          </a:p>
-        </p:txBody>
-      </p:sp>
-      <p:sp>
-        <p:nvSpPr>
-          <p:cNvPr id="17" name="Rounded Rectangle 16"/>
+              <a:t>92.1% of external errors are unsupported-site related</a:t>
+            </a:r>
+          </a:p>
+        </p:txBody>
+      </p:sp>
+      <p:sp>
+        <p:nvSpPr>
+          <p:cNvPr id="18" name="Rounded Rectangle 17"/>
           <p:cNvSpPr/>
           <p:nvPr/>
         </p:nvSpPr>
@@ -4674,7 +4725,7 @@
           <a:solidFill>
             <a:srgbClr val="FFFFFF"/>
           </a:solidFill>
-          <a:ln w="15240">
+          <a:ln w="16510">
             <a:solidFill>
               <a:srgbClr val="D95F5F"/>
             </a:solidFill>
@@ -4695,27 +4746,50 @@
           </a:fontRef>
         </p:style>
         <p:txBody>
-          <a:bodyPr rtlCol="0" anchor="ctr" wrap="square" lIns="109728" rIns="109728" tIns="109728" bIns="109728">
-            <a:normAutofit/>
+          <a:bodyPr rtlCol="0" anchor="ctr"/>
+          <a:lstStyle/>
+          <a:p>
+            <a:pPr algn="ctr"/>
+          </a:p>
+        </p:txBody>
+      </p:sp>
+      <p:sp>
+        <p:nvSpPr>
+          <p:cNvPr id="19" name="TextBox 18"/>
+          <p:cNvSpPr txBox="1"/>
+          <p:nvPr/>
+        </p:nvSpPr>
+        <p:spPr>
+          <a:xfrm>
+            <a:off x="7525512" y="3218688"/>
+            <a:ext cx="3977639" cy="685800"/>
+          </a:xfrm>
+          <a:prstGeom prst="rect">
+            <a:avLst/>
+          </a:prstGeom>
+          <a:noFill/>
+        </p:spPr>
+        <p:txBody>
+          <a:bodyPr wrap="none">
+            <a:spAutoFit/>
           </a:bodyPr>
           <a:lstStyle/>
           <a:p>
-            <a:pPr algn="l"/>
-            <a:r>
-              <a:rPr sz="2200" b="1">
+            <a:r>
+              <a:rPr sz="2000" b="1">
                 <a:solidFill>
                   <a:srgbClr val="0B1F3A"/>
                 </a:solidFill>
-                <a:latin typeface="Aptos"/>
+                <a:latin typeface="Aptos Display"/>
               </a:rPr>
-              <a:t>84% of product errors come from general_fail + bookmark_fail</a:t>
-            </a:r>
-          </a:p>
-        </p:txBody>
-      </p:sp>
-      <p:sp>
-        <p:nvSpPr>
-          <p:cNvPr id="18" name="Rounded Rectangle 17"/>
+              <a:t>84.2% of product errors come from general_fail + bookmark_fail</a:t>
+            </a:r>
+          </a:p>
+        </p:txBody>
+      </p:sp>
+      <p:sp>
+        <p:nvSpPr>
+          <p:cNvPr id="20" name="Rounded Rectangle 19"/>
           <p:cNvSpPr/>
           <p:nvPr/>
         </p:nvSpPr>
@@ -4749,7 +4823,7 @@
           </a:fontRef>
         </p:style>
         <p:txBody>
-          <a:bodyPr rtlCol="0" anchor="ctr" wrap="square" lIns="164592" rIns="164592" tIns="128016"/>
+          <a:bodyPr rtlCol="0" anchor="ctr" wrap="square"/>
           <a:lstStyle/>
           <a:p>
             <a:pPr algn="ctr"/>
@@ -4815,14 +4889,14 @@
       </p:sp>
       <p:sp>
         <p:nvSpPr>
-          <p:cNvPr id="19" name="TextBox 18"/>
+          <p:cNvPr id="21" name="TextBox 20"/>
           <p:cNvSpPr txBox="1"/>
           <p:nvPr/>
         </p:nvSpPr>
         <p:spPr>
           <a:xfrm>
             <a:off x="530352" y="6419088"/>
-            <a:ext cx="10972800" cy="228600"/>
+            <a:ext cx="10972800" cy="201168"/>
           </a:xfrm>
           <a:prstGeom prst="rect">
             <a:avLst/>

</xml_diff>

<commit_message>
Reframe stakeholder deck as three-phase progression
Co-authored-by: ChantelleJ-pm <ChantelleJ-pm@users.noreply.github.com>
</commit_message>
<xml_diff>
--- a/Recipe_Clipper_Stakeholder_Update.pptx
+++ b/Recipe_Clipper_Stakeholder_Update.pptx
@@ -3164,13 +3164,13 @@
           <a:lstStyle/>
           <a:p>
             <a:r>
-              <a:rPr sz="2600" b="1">
+              <a:rPr sz="2400" b="1">
                 <a:solidFill>
                   <a:srgbClr val="0B1F3A"/>
                 </a:solidFill>
                 <a:latin typeface="Aptos Display"/>
               </a:rPr>
-              <a:t>Recipe Clipper is performing better now than it was before February</a:t>
+              <a:t>Recipe Clipper performance improved in stages</a:t>
             </a:r>
           </a:p>
         </p:txBody>
@@ -3204,7 +3204,7 @@
                 </a:solidFill>
                 <a:latin typeface="Aptos"/>
               </a:rPr>
-              <a:t>Pre-Feb vs post-mid-Feb shows stronger save performance, faster save-click time, and continued external adoption.</a:t>
+              <a:t>A three-phase view shows improvement through the transition window and into the cleaner post-mid-Feb period.</a:t>
             </a:r>
           </a:p>
         </p:txBody>
@@ -3339,8 +3339,8 @@
         </p:nvSpPr>
         <p:spPr>
           <a:xfrm>
-            <a:off x="694944" y="2395728"/>
-            <a:ext cx="3328416" cy="685800"/>
+            <a:off x="694944" y="2377440"/>
+            <a:ext cx="3328416" cy="731520"/>
           </a:xfrm>
           <a:prstGeom prst="rect">
             <a:avLst/>
@@ -3354,13 +3354,13 @@
           <a:lstStyle/>
           <a:p>
             <a:r>
-              <a:rPr sz="2400" b="1">
+              <a:rPr sz="2200" b="1">
                 <a:solidFill>
                   <a:srgbClr val="0B1F3A"/>
                 </a:solidFill>
                 <a:latin typeface="Aptos Display"/>
               </a:rPr>
-              <a:t>40.5% -&gt; 52.1%</a:t>
+              <a:t>40.5% -&gt; 47.2% -&gt; 52.1%</a:t>
             </a:r>
           </a:p>
         </p:txBody>
@@ -3373,8 +3373,8 @@
         </p:nvSpPr>
         <p:spPr>
           <a:xfrm>
-            <a:off x="694944" y="3090672"/>
-            <a:ext cx="3328416" cy="502920"/>
+            <a:off x="694944" y="3054096"/>
+            <a:ext cx="3328416" cy="530352"/>
           </a:xfrm>
           <a:prstGeom prst="rect">
             <a:avLst/>
@@ -3388,13 +3388,13 @@
           <a:lstStyle/>
           <a:p>
             <a:r>
-              <a:rPr sz="1100">
+              <a:rPr sz="1050">
                 <a:solidFill>
                   <a:srgbClr val="667085"/>
                 </a:solidFill>
                 <a:latin typeface="Aptos"/>
               </a:rPr>
-              <a:t>Pre-Feb (12/18-1/31) -&gt; post-mid-Feb (2/19-3/18)</a:t>
+              <a:t>Baseline (12/18-1/30) -&gt; transition (1/31-2/18) -&gt; post-mid-Feb (2/19-3/18)</a:t>
             </a:r>
           </a:p>
         </p:txBody>
@@ -3529,8 +3529,8 @@
         </p:nvSpPr>
         <p:spPr>
           <a:xfrm>
-            <a:off x="4453128" y="2395728"/>
-            <a:ext cx="3328416" cy="685800"/>
+            <a:off x="4453128" y="2377440"/>
+            <a:ext cx="3328416" cy="731520"/>
           </a:xfrm>
           <a:prstGeom prst="rect">
             <a:avLst/>
@@ -3544,13 +3544,13 @@
           <a:lstStyle/>
           <a:p>
             <a:r>
-              <a:rPr sz="2400" b="1">
+              <a:rPr sz="2200" b="1">
                 <a:solidFill>
                   <a:srgbClr val="0B1F3A"/>
                 </a:solidFill>
                 <a:latin typeface="Aptos Display"/>
               </a:rPr>
-              <a:t>5.1s -&gt; 3.8s</a:t>
+              <a:t>5.1s -&gt; 4.7s -&gt; 3.8s</a:t>
             </a:r>
           </a:p>
         </p:txBody>
@@ -3563,8 +3563,8 @@
         </p:nvSpPr>
         <p:spPr>
           <a:xfrm>
-            <a:off x="4453128" y="3090672"/>
-            <a:ext cx="3328416" cy="502920"/>
+            <a:off x="4453128" y="3054096"/>
+            <a:ext cx="3328416" cy="530352"/>
           </a:xfrm>
           <a:prstGeom prst="rect">
             <a:avLst/>
@@ -3578,13 +3578,13 @@
           <a:lstStyle/>
           <a:p>
             <a:r>
-              <a:rPr sz="1100">
+              <a:rPr sz="1050">
                 <a:solidFill>
                   <a:srgbClr val="667085"/>
                 </a:solidFill>
                 <a:latin typeface="Aptos"/>
               </a:rPr>
-              <a:t>Pre-Feb (12/18-1/31) -&gt; post-mid-Feb (2/19-3/18)</a:t>
+              <a:t>Baseline (12/18-1/30) -&gt; transition (1/31-2/18) -&gt; post-mid-Feb (2/19-3/18)</a:t>
             </a:r>
           </a:p>
         </p:txBody>
@@ -3706,7 +3706,7 @@
                 </a:solidFill>
                 <a:latin typeface="Aptos"/>
               </a:rPr>
-              <a:t>External-brand adoption</a:t>
+              <a:t>External-brand share of successful saves</a:t>
             </a:r>
           </a:p>
         </p:txBody>
@@ -3719,8 +3719,8 @@
         </p:nvSpPr>
         <p:spPr>
           <a:xfrm>
-            <a:off x="8211312" y="2395728"/>
-            <a:ext cx="3328416" cy="685800"/>
+            <a:off x="8211312" y="2377440"/>
+            <a:ext cx="3328416" cy="731520"/>
           </a:xfrm>
           <a:prstGeom prst="rect">
             <a:avLst/>
@@ -3734,13 +3734,13 @@
           <a:lstStyle/>
           <a:p>
             <a:r>
-              <a:rPr sz="2400" b="1">
+              <a:rPr sz="2200" b="1">
                 <a:solidFill>
                   <a:srgbClr val="0B1F3A"/>
                 </a:solidFill>
                 <a:latin typeface="Aptos Display"/>
               </a:rPr>
-              <a:t>78.8% -&gt; 85.3%</a:t>
+              <a:t>79.0% -&gt; 79.1% -&gt; 85.3%</a:t>
             </a:r>
           </a:p>
         </p:txBody>
@@ -3753,8 +3753,8 @@
         </p:nvSpPr>
         <p:spPr>
           <a:xfrm>
-            <a:off x="8211312" y="3090672"/>
-            <a:ext cx="3328416" cy="502920"/>
+            <a:off x="8211312" y="3054096"/>
+            <a:ext cx="3328416" cy="530352"/>
           </a:xfrm>
           <a:prstGeom prst="rect">
             <a:avLst/>
@@ -3768,7 +3768,7 @@
           <a:lstStyle/>
           <a:p>
             <a:r>
-              <a:rPr sz="1100">
+              <a:rPr sz="1050">
                 <a:solidFill>
                   <a:srgbClr val="667085"/>
                 </a:solidFill>
@@ -3892,7 +3892,7 @@
               </a:defRPr>
             </a:pPr>
             <a:r>
-              <a:t>126 supported sites were added on Feb 9</a:t>
+              <a:t>126 supported sites were added on Feb 9 during the transition period</a:t>
             </a:r>
           </a:p>
           <a:p>
@@ -3908,7 +3908,7 @@
               </a:defRPr>
             </a:pPr>
             <a:r>
-              <a:t>Average daily save attempt success rate improved from 44.1% in Feb 1-8 to 50.3% in Feb 9-18</a:t>
+              <a:t>Performance improves in stages, with gains visible in the transition window and further gains in the trusted post-mid-Feb period</a:t>
             </a:r>
           </a:p>
           <a:p>
@@ -3924,7 +3924,7 @@
               </a:defRPr>
             </a:pPr>
             <a:r>
-              <a:t>User error rate improved from 35.1% to 24.9% of submissions in the immediate pre/post Feb 9 window</a:t>
+              <a:t>Use 2/19 onward for trusted user vs product vs external error attribution</a:t>
             </a:r>
           </a:p>
         </p:txBody>
@@ -3965,12 +3965,37 @@
           </a:fontRef>
         </p:style>
         <p:txBody>
-          <a:bodyPr rtlCol="0" anchor="ctr" wrap="square"/>
+          <a:bodyPr rtlCol="0" anchor="ctr"/>
           <a:lstStyle/>
           <a:p>
             <a:pPr algn="ctr"/>
-            <a:r>
-              <a:rPr sz="1600" b="1">
+          </a:p>
+        </p:txBody>
+      </p:sp>
+      <p:sp>
+        <p:nvSpPr>
+          <p:cNvPr id="24" name="TextBox 23"/>
+          <p:cNvSpPr txBox="1"/>
+          <p:nvPr/>
+        </p:nvSpPr>
+        <p:spPr>
+          <a:xfrm>
+            <a:off x="7498080" y="4014216"/>
+            <a:ext cx="4041648" cy="274320"/>
+          </a:xfrm>
+          <a:prstGeom prst="rect">
+            <a:avLst/>
+          </a:prstGeom>
+          <a:noFill/>
+        </p:spPr>
+        <p:txBody>
+          <a:bodyPr wrap="none">
+            <a:spAutoFit/>
+          </a:bodyPr>
+          <a:lstStyle/>
+          <a:p>
+            <a:r>
+              <a:rPr sz="1400" b="1">
                 <a:solidFill>
                   <a:srgbClr val="FFFFFF"/>
                 </a:solidFill>
@@ -3979,12 +4004,35 @@
               <a:t>Stakeholder takeaway</a:t>
             </a:r>
           </a:p>
+        </p:txBody>
+      </p:sp>
+      <p:sp>
+        <p:nvSpPr>
+          <p:cNvPr id="25" name="TextBox 24"/>
+          <p:cNvSpPr txBox="1"/>
+          <p:nvPr/>
+        </p:nvSpPr>
+        <p:spPr>
+          <a:xfrm>
+            <a:off x="7479792" y="4343400"/>
+            <a:ext cx="4078224" cy="1673352"/>
+          </a:xfrm>
+          <a:prstGeom prst="rect">
+            <a:avLst/>
+          </a:prstGeom>
+          <a:noFill/>
+        </p:spPr>
+        <p:txBody>
+          <a:bodyPr wrap="square" lIns="45720">
+            <a:spAutoFit/>
+          </a:bodyPr>
+          <a:lstStyle/>
           <a:p>
             <a:pPr>
               <a:spcAft>
                 <a:spcPts val="800"/>
               </a:spcAft>
-              <a:defRPr sz="1500">
+              <a:defRPr sz="1400">
                 <a:solidFill>
                   <a:srgbClr val="FFFFFF"/>
                 </a:solidFill>
@@ -3992,7 +4040,7 @@
               </a:defRPr>
             </a:pPr>
             <a:r>
-              <a:t>We are performing better now than we were before February on the leading KPIs visible in this export.</a:t>
+              <a:t>We can show steady KPI improvement across three phases instead of forcing a single before/after cut.</a:t>
             </a:r>
           </a:p>
           <a:p>
@@ -4000,7 +4048,7 @@
               <a:spcAft>
                 <a:spcPts val="800"/>
               </a:spcAft>
-              <a:defRPr sz="1500">
+              <a:defRPr sz="1400">
                 <a:solidFill>
                   <a:srgbClr val="FFFFFF"/>
                 </a:solidFill>
@@ -4015,7 +4063,7 @@
       </p:sp>
       <p:sp>
         <p:nvSpPr>
-          <p:cNvPr id="24" name="TextBox 23"/>
+          <p:cNvPr id="26" name="TextBox 25"/>
           <p:cNvSpPr txBox="1"/>
           <p:nvPr/>
         </p:nvSpPr>
@@ -4042,7 +4090,7 @@
                 </a:solidFill>
                 <a:latin typeface="Aptos"/>
               </a:rPr>
-              <a:t>Use pre-Feb vs post-mid-Feb for the topline before/after story. Use 2/19 onward as the trusted source for user vs product vs external error attribution.</a:t>
+              <a:t>Use the three-phase view for KPI progression. Use 2/19 onward as the trusted source for user vs product vs external error attribution.</a:t>
             </a:r>
           </a:p>
         </p:txBody>
@@ -4140,13 +4188,13 @@
           <a:lstStyle/>
           <a:p>
             <a:r>
-              <a:rPr sz="2600" b="1">
+              <a:rPr sz="2400" b="1">
                 <a:solidFill>
                   <a:srgbClr val="0B1F3A"/>
                 </a:solidFill>
                 <a:latin typeface="Aptos Display"/>
               </a:rPr>
-              <a:t>Remaining friction is mostly user and site coverage, not core product reliability</a:t>
+              <a:t>Post-mid-Feb error mix shows site coverage is the main remaining scaling constraint</a:t>
             </a:r>
           </a:p>
         </p:txBody>
@@ -4180,7 +4228,7 @@
                 </a:solidFill>
                 <a:latin typeface="Aptos"/>
               </a:rPr>
-              <a:t>Use share of save attempts, not share of failures, to keep the denominator stakeholder-safe.</a:t>
+              <a:t>From 2/19 onward, error attribution is the cleanest read of user vs product vs external friction.</a:t>
             </a:r>
           </a:p>
         </p:txBody>
@@ -4563,7 +4611,7 @@
           <a:p>
             <a:pPr algn="ctr"/>
             <a:r>
-              <a:rPr sz="1200" b="1">
+              <a:rPr sz="1300" b="1">
                 <a:solidFill>
                   <a:srgbClr val="FFFFFF"/>
                 </a:solidFill>
@@ -4823,12 +4871,37 @@
           </a:fontRef>
         </p:style>
         <p:txBody>
-          <a:bodyPr rtlCol="0" anchor="ctr" wrap="square"/>
+          <a:bodyPr rtlCol="0" anchor="ctr"/>
           <a:lstStyle/>
           <a:p>
             <a:pPr algn="ctr"/>
-            <a:r>
-              <a:rPr sz="1600" b="1">
+          </a:p>
+        </p:txBody>
+      </p:sp>
+      <p:sp>
+        <p:nvSpPr>
+          <p:cNvPr id="21" name="TextBox 20"/>
+          <p:cNvSpPr txBox="1"/>
+          <p:nvPr/>
+        </p:nvSpPr>
+        <p:spPr>
+          <a:xfrm>
+            <a:off x="7525512" y="4443984"/>
+            <a:ext cx="4014216" cy="274320"/>
+          </a:xfrm>
+          <a:prstGeom prst="rect">
+            <a:avLst/>
+          </a:prstGeom>
+          <a:noFill/>
+        </p:spPr>
+        <p:txBody>
+          <a:bodyPr wrap="none">
+            <a:spAutoFit/>
+          </a:bodyPr>
+          <a:lstStyle/>
+          <a:p>
+            <a:r>
+              <a:rPr sz="1400" b="1">
                 <a:solidFill>
                   <a:srgbClr val="FFFFFF"/>
                 </a:solidFill>
@@ -4837,12 +4910,35 @@
               <a:t>What we should do next</a:t>
             </a:r>
           </a:p>
+        </p:txBody>
+      </p:sp>
+      <p:sp>
+        <p:nvSpPr>
+          <p:cNvPr id="22" name="TextBox 21"/>
+          <p:cNvSpPr txBox="1"/>
+          <p:nvPr/>
+        </p:nvSpPr>
+        <p:spPr>
+          <a:xfrm>
+            <a:off x="7507224" y="4773168"/>
+            <a:ext cx="4050792" cy="1124712"/>
+          </a:xfrm>
+          <a:prstGeom prst="rect">
+            <a:avLst/>
+          </a:prstGeom>
+          <a:noFill/>
+        </p:spPr>
+        <p:txBody>
+          <a:bodyPr wrap="square" lIns="45720">
+            <a:spAutoFit/>
+          </a:bodyPr>
+          <a:lstStyle/>
           <a:p>
             <a:pPr>
               <a:spcAft>
-                <a:spcPts val="600"/>
+                <a:spcPts val="800"/>
               </a:spcAft>
-              <a:defRPr sz="1500">
+              <a:defRPr sz="1400">
                 <a:solidFill>
                   <a:srgbClr val="FFFFFF"/>
                 </a:solidFill>
@@ -4856,9 +4952,9 @@
           <a:p>
             <a:pPr>
               <a:spcAft>
-                <a:spcPts val="600"/>
+                <a:spcPts val="800"/>
               </a:spcAft>
-              <a:defRPr sz="1500">
+              <a:defRPr sz="1400">
                 <a:solidFill>
                   <a:srgbClr val="FFFFFF"/>
                 </a:solidFill>
@@ -4872,9 +4968,9 @@
           <a:p>
             <a:pPr>
               <a:spcAft>
-                <a:spcPts val="600"/>
+                <a:spcPts val="800"/>
               </a:spcAft>
-              <a:defRPr sz="1500">
+              <a:defRPr sz="1400">
                 <a:solidFill>
                   <a:srgbClr val="FFFFFF"/>
                 </a:solidFill>
@@ -4889,7 +4985,7 @@
       </p:sp>
       <p:sp>
         <p:nvSpPr>
-          <p:cNvPr id="21" name="TextBox 20"/>
+          <p:cNvPr id="23" name="TextBox 22"/>
           <p:cNvSpPr txBox="1"/>
           <p:nvPr/>
         </p:nvSpPr>

</xml_diff>